<commit_message>
README e pequenos ajustes no notebook e slides feitos
</commit_message>
<xml_diff>
--- a/reports/slides/apresentacao_slides.pptx
+++ b/reports/slides/apresentacao_slides.pptx
@@ -114,6 +114,11 @@
       </a:defRPr>
     </a:lvl9pPr>
   </p:defaultTextStyle>
+  <p:extLst>
+    <p:ext uri="{EFAFB233-063F-42B5-8137-9DF3F51BA10A}">
+      <p15:sldGuideLst xmlns:p15="http://schemas.microsoft.com/office/powerpoint/2012/main"/>
+    </p:ext>
+  </p:extLst>
 </p:presentation>
 </file>
 
@@ -302,7 +307,7 @@
           <a:p>
             <a:fld id="{9AB3A824-1A51-4B26-AD58-A6D8E14F6C04}" type="datetimeFigureOut">
               <a:rPr lang="en-US" smtClean="0"/>
-              <a:t>4/26/2026</a:t>
+              <a:t>4/28/2026</a:t>
             </a:fld>
             <a:endParaRPr lang="en-US" dirty="0"/>
           </a:p>
@@ -605,7 +610,7 @@
           <a:p>
             <a:fld id="{3CBC1C18-307B-4F68-A007-B5B542270E8D}" type="datetimeFigureOut">
               <a:rPr lang="en-US" smtClean="0"/>
-              <a:t>4/26/2026</a:t>
+              <a:t>4/28/2026</a:t>
             </a:fld>
             <a:endParaRPr lang="en-US" dirty="0"/>
           </a:p>
@@ -804,7 +809,7 @@
           <a:p>
             <a:fld id="{3CBC1C18-307B-4F68-A007-B5B542270E8D}" type="datetimeFigureOut">
               <a:rPr lang="en-US" smtClean="0"/>
-              <a:t>4/26/2026</a:t>
+              <a:t>4/28/2026</a:t>
             </a:fld>
             <a:endParaRPr lang="en-US" dirty="0"/>
           </a:p>
@@ -1072,7 +1077,7 @@
           <a:p>
             <a:fld id="{3CBC1C18-307B-4F68-A007-B5B542270E8D}" type="datetimeFigureOut">
               <a:rPr lang="en-US" smtClean="0"/>
-              <a:t>4/26/2026</a:t>
+              <a:t>4/28/2026</a:t>
             </a:fld>
             <a:endParaRPr lang="en-US" dirty="0"/>
           </a:p>
@@ -1503,7 +1508,7 @@
           <a:p>
             <a:fld id="{3CBC1C18-307B-4F68-A007-B5B542270E8D}" type="datetimeFigureOut">
               <a:rPr lang="en-US" smtClean="0"/>
-              <a:t>4/26/2026</a:t>
+              <a:t>4/28/2026</a:t>
             </a:fld>
             <a:endParaRPr lang="en-US" dirty="0"/>
           </a:p>
@@ -2047,7 +2052,7 @@
           <a:p>
             <a:fld id="{3CBC1C18-307B-4F68-A007-B5B542270E8D}" type="datetimeFigureOut">
               <a:rPr lang="en-US" smtClean="0"/>
-              <a:t>4/26/2026</a:t>
+              <a:t>4/28/2026</a:t>
             </a:fld>
             <a:endParaRPr lang="en-US" dirty="0"/>
           </a:p>
@@ -2918,7 +2923,7 @@
           <a:p>
             <a:fld id="{3CBC1C18-307B-4F68-A007-B5B542270E8D}" type="datetimeFigureOut">
               <a:rPr lang="en-US" smtClean="0"/>
-              <a:t>4/26/2026</a:t>
+              <a:t>4/28/2026</a:t>
             </a:fld>
             <a:endParaRPr lang="en-US" dirty="0"/>
           </a:p>
@@ -3095,7 +3100,7 @@
           <a:p>
             <a:fld id="{D857E33E-8B18-4087-B112-809917729534}" type="datetimeFigureOut">
               <a:rPr lang="en-US" smtClean="0"/>
-              <a:t>4/26/2026</a:t>
+              <a:t>4/28/2026</a:t>
             </a:fld>
             <a:endParaRPr lang="en-US" dirty="0"/>
           </a:p>
@@ -3284,7 +3289,7 @@
           <a:p>
             <a:fld id="{D3FFE419-2371-464F-8239-3959401C3561}" type="datetimeFigureOut">
               <a:rPr lang="en-US" smtClean="0"/>
-              <a:t>4/26/2026</a:t>
+              <a:t>4/28/2026</a:t>
             </a:fld>
             <a:endParaRPr lang="en-US" dirty="0"/>
           </a:p>
@@ -3459,7 +3464,7 @@
           <a:p>
             <a:fld id="{97D162C4-EDD9-4389-A98B-B87ECEA2A816}" type="datetimeFigureOut">
               <a:rPr lang="en-US" smtClean="0"/>
-              <a:t>4/26/2026</a:t>
+              <a:t>4/28/2026</a:t>
             </a:fld>
             <a:endParaRPr lang="en-US" dirty="0"/>
           </a:p>
@@ -3708,7 +3713,7 @@
           <a:p>
             <a:fld id="{3E5059C3-6A89-4494-99FF-5A4D6FFD50EB}" type="datetimeFigureOut">
               <a:rPr lang="en-US" smtClean="0"/>
-              <a:t>4/26/2026</a:t>
+              <a:t>4/28/2026</a:t>
             </a:fld>
             <a:endParaRPr lang="en-US" dirty="0"/>
           </a:p>
@@ -3949,7 +3954,7 @@
           <a:p>
             <a:fld id="{CA954B2F-12DE-47F5-8894-472B206D2E1E}" type="datetimeFigureOut">
               <a:rPr lang="en-US" smtClean="0"/>
-              <a:t>4/26/2026</a:t>
+              <a:t>4/28/2026</a:t>
             </a:fld>
             <a:endParaRPr lang="en-US" dirty="0"/>
           </a:p>
@@ -4420,7 +4425,7 @@
           <a:p>
             <a:fld id="{3F30E46F-7819-4ACF-B48B-48222C2ACC88}" type="datetimeFigureOut">
               <a:rPr lang="en-US" smtClean="0"/>
-              <a:t>4/26/2026</a:t>
+              <a:t>4/28/2026</a:t>
             </a:fld>
             <a:endParaRPr lang="en-US" dirty="0"/>
           </a:p>
@@ -4543,7 +4548,7 @@
           <a:p>
             <a:fld id="{1FAF3416-4057-4DAA-829D-4CA07428D088}" type="datetimeFigureOut">
               <a:rPr lang="en-US" smtClean="0"/>
-              <a:t>4/26/2026</a:t>
+              <a:t>4/28/2026</a:t>
             </a:fld>
             <a:endParaRPr lang="en-US" dirty="0"/>
           </a:p>
@@ -4643,7 +4648,7 @@
           <a:p>
             <a:fld id="{921D9284-D300-4297-87F7-E791DCC15DB1}" type="datetimeFigureOut">
               <a:rPr lang="en-US" smtClean="0"/>
-              <a:t>4/26/2026</a:t>
+              <a:t>4/28/2026</a:t>
             </a:fld>
             <a:endParaRPr lang="en-US" dirty="0"/>
           </a:p>
@@ -4903,7 +4908,7 @@
           <a:p>
             <a:fld id="{37D525BB-DA17-4BA0-B3C8-3AC3ABC827E6}" type="datetimeFigureOut">
               <a:rPr lang="en-US" smtClean="0"/>
-              <a:t>4/26/2026</a:t>
+              <a:t>4/28/2026</a:t>
             </a:fld>
             <a:endParaRPr lang="en-US" dirty="0"/>
           </a:p>
@@ -5208,7 +5213,7 @@
           <a:p>
             <a:fld id="{B16C4C9A-3960-41CF-A4E9-2A8FB932454B}" type="datetimeFigureOut">
               <a:rPr lang="en-US" smtClean="0"/>
-              <a:t>4/26/2026</a:t>
+              <a:t>4/28/2026</a:t>
             </a:fld>
             <a:endParaRPr lang="en-US" dirty="0"/>
           </a:p>
@@ -5447,7 +5452,7 @@
           <a:p>
             <a:fld id="{3CBC1C18-307B-4F68-A007-B5B542270E8D}" type="datetimeFigureOut">
               <a:rPr lang="en-US" smtClean="0"/>
-              <a:t>4/26/2026</a:t>
+              <a:t>4/28/2026</a:t>
             </a:fld>
             <a:endParaRPr lang="en-US" dirty="0"/>
           </a:p>
@@ -6593,7 +6598,7 @@
           <a:p>
             <a:r>
               <a:rPr lang="pt-BR" dirty="0"/>
-              <a:t>Guilherme Alvarez</a:t>
+              <a:t>Guilherme Alvarez - 2026</a:t>
             </a:r>
           </a:p>
         </p:txBody>
@@ -8766,7 +8771,7 @@
         </p:spPr>
         <p:txBody>
           <a:bodyPr vert="horz" lIns="91440" tIns="45720" rIns="91440" bIns="45720" rtlCol="0" anchor="t">
-            <a:normAutofit/>
+            <a:normAutofit lnSpcReduction="10000"/>
           </a:bodyPr>
           <a:lstStyle>
             <a:lvl1pPr marL="0" indent="0" algn="ctr" defTabSz="457200" rtl="0" eaLnBrk="1" latinLnBrk="0" hangingPunct="1">
@@ -9140,7 +9145,53 @@
             </a:br>
             <a:r>
               <a:rPr lang="pt-BR" sz="1800" dirty="0"/>
-              <a:t>Esse crescimento trouxe desafios na consistência da experiência do cliente, refletidos na variabilidade do Net Promoter Score (NPS) entre diferentes perfis de consumidores.</a:t>
+              <a:t>Esse crescimento trouxe desafios na consistência da experiência do cliente, refletidos na variabilidade do Net Promoter Score (NPS).</a:t>
+            </a:r>
+          </a:p>
+          <a:p>
+            <a:endParaRPr lang="pt-BR" sz="1800" dirty="0"/>
+          </a:p>
+          <a:p>
+            <a:r>
+              <a:rPr lang="pt-BR" sz="1800" dirty="0"/>
+              <a:t>O Net Promoter Score (NPS) é uma métrica de satisfação do cliente baseada na probabilidade de recomendação da empresa.</a:t>
+            </a:r>
+            <a:br>
+              <a:rPr lang="pt-BR" sz="1800" dirty="0"/>
+            </a:br>
+            <a:r>
+              <a:rPr lang="pt-BR" sz="1800" dirty="0"/>
+              <a:t>Os clientes são classificados em três grupos:</a:t>
+            </a:r>
+          </a:p>
+          <a:p>
+            <a:r>
+              <a:rPr lang="pt-BR" sz="1800" b="1" dirty="0"/>
+              <a:t>Detratores (0–6):</a:t>
+            </a:r>
+            <a:r>
+              <a:rPr lang="pt-BR" sz="1800" dirty="0"/>
+              <a:t> clientes insatisfeitos, com potencial de impacto negativo na reputação </a:t>
+            </a:r>
+          </a:p>
+          <a:p>
+            <a:r>
+              <a:rPr lang="pt-BR" sz="1800" b="1" dirty="0"/>
+              <a:t>Neutros (7–8):</a:t>
+            </a:r>
+            <a:r>
+              <a:rPr lang="pt-BR" sz="1800" dirty="0"/>
+              <a:t> clientes satisfeitos, porém com baixo nível de engajamento </a:t>
+            </a:r>
+          </a:p>
+          <a:p>
+            <a:r>
+              <a:rPr lang="pt-BR" sz="1800" b="1" dirty="0"/>
+              <a:t>Promotores (9–10):</a:t>
+            </a:r>
+            <a:r>
+              <a:rPr lang="pt-BR" sz="1800" dirty="0"/>
+              <a:t> clientes leais, com alta propensão a recomendar a empresa</a:t>
             </a:r>
           </a:p>
           <a:p>
@@ -10469,7 +10520,7 @@
           <a:p>
             <a:r>
               <a:rPr lang="pt-BR" dirty="0"/>
-              <a:t>Net Promoter Score</a:t>
+              <a:t>Importância do NPS para E-commerce</a:t>
             </a:r>
           </a:p>
         </p:txBody>
@@ -10506,7 +10557,7 @@
         </p:spPr>
         <p:txBody>
           <a:bodyPr vert="horz" lIns="91440" tIns="45720" rIns="91440" bIns="45720" rtlCol="0" anchor="t">
-            <a:normAutofit fontScale="77500" lnSpcReduction="20000"/>
+            <a:normAutofit lnSpcReduction="10000"/>
           </a:bodyPr>
           <a:lstStyle>
             <a:lvl1pPr marL="0" indent="0" algn="ctr" defTabSz="457200" rtl="0" eaLnBrk="1" latinLnBrk="0" hangingPunct="1">
@@ -10869,56 +10920,7 @@
             </a:lvl9pPr>
           </a:lstStyle>
           <a:p>
-            <a:r>
-              <a:rPr lang="pt-BR" sz="1800" dirty="0"/>
-              <a:t>O Net Promoter Score (NPS) é uma métrica de satisfação do cliente baseada na probabilidade de recomendação da empresa.</a:t>
-            </a:r>
-            <a:br>
-              <a:rPr lang="pt-BR" sz="1800" dirty="0"/>
-            </a:br>
-            <a:r>
-              <a:rPr lang="pt-BR" sz="1800" dirty="0"/>
-              <a:t>Os clientes são classificados em três grupos:</a:t>
-            </a:r>
-          </a:p>
-          <a:p>
-            <a:r>
-              <a:rPr lang="pt-BR" sz="1800" b="1" dirty="0"/>
-              <a:t>Detratores (0–6):</a:t>
-            </a:r>
-            <a:r>
-              <a:rPr lang="pt-BR" sz="1800" dirty="0"/>
-              <a:t> clientes insatisfeitos, com potencial de impacto negativo na reputação </a:t>
-            </a:r>
-          </a:p>
-          <a:p>
-            <a:r>
-              <a:rPr lang="pt-BR" sz="1800" b="1" dirty="0"/>
-              <a:t>Neutros (7–8):</a:t>
-            </a:r>
-            <a:r>
-              <a:rPr lang="pt-BR" sz="1800" dirty="0"/>
-              <a:t> clientes satisfeitos, porém com baixo nível de engajamento </a:t>
-            </a:r>
-          </a:p>
-          <a:p>
-            <a:r>
-              <a:rPr lang="pt-BR" sz="1800" b="1" dirty="0"/>
-              <a:t>Promotores (9–10):</a:t>
-            </a:r>
-            <a:r>
-              <a:rPr lang="pt-BR" sz="1800" dirty="0"/>
-              <a:t> clientes leais, com alta propensão a recomendar a empresa</a:t>
-            </a:r>
-          </a:p>
-          <a:p>
             <a:endParaRPr lang="pt-BR" sz="1800" dirty="0"/>
-          </a:p>
-          <a:p>
-            <a:r>
-              <a:rPr lang="pt-BR" sz="2600" dirty="0"/>
-              <a:t>Importância do NPS para E-commerce</a:t>
-            </a:r>
           </a:p>
           <a:p>
             <a:r>

</xml_diff>